<commit_message>
Add QR code + URL to every talk deck slide, update stale taglines
Every slide in the volunteer talk deck now carries a QR code and
trustbutverifyproject.org, not just the last one, with two QR color
variants so it reads against both dark and light slide backgrounds.
Also updated the title/closing slide taglines to match the site's
current "You can stay trusting, but add a pause" line, and fixed the
build script's output path, which was hardcoded to a nonexistent
cloud-sandbox location and silently not writing into the repo.

Co-Authored-By: Claude Sonnet 5 <noreply@anthropic.com>
</commit_message>
<xml_diff>
--- a/formats/talk/trust-but-verify-talk.pptx
+++ b/formats/talk/trust-but-verify-talk.pptx
@@ -2786,6 +2786,69 @@
         </p:nvSpPr>
         <p:spPr>
           <a:xfrm>
+            <a:off x="685800" y="6400800"/>
+            <a:ext cx="5486400" cy="384048"/>
+          </a:xfrm>
+          <a:prstGeom prst="rect">
+            <a:avLst/>
+          </a:prstGeom>
+          <a:noFill/>
+          <a:ln/>
+        </p:spPr>
+        <p:txBody>
+          <a:bodyPr wrap="square" lIns="0" tIns="0" rIns="0" bIns="0" rtlCol="0" anchor="ctr"/>
+          <a:lstStyle/>
+          <a:p>
+            <a:pPr indent="0" marL="0">
+              <a:buNone/>
+            </a:pPr>
+            <a:r>
+              <a:rPr lang="en-US" sz="1200" dirty="0">
+                <a:solidFill>
+                  <a:srgbClr val="9A958C"/>
+                </a:solidFill>
+                <a:latin typeface="Arial" pitchFamily="34" charset="0"/>
+                <a:ea typeface="Arial" pitchFamily="34" charset="-122"/>
+                <a:cs typeface="Arial" pitchFamily="34" charset="-120"/>
+              </a:rPr>
+              <a:t>trustbutverifyproject.org</a:t>
+            </a:r>
+            <a:endParaRPr lang="en-US" sz="1200" dirty="0"/>
+          </a:p>
+        </p:txBody>
+      </p:sp>
+      <p:pic>
+        <p:nvPicPr>
+          <p:cNvPr id="4" name="Image 0" descr="/Users/brettmorrison/Claude/trustbutverify-site/build/deck-assets/qr-paper.png">    </p:cNvPr>
+          <p:cNvPicPr>
+            <a:picLocks noChangeAspect="1"/>
+          </p:cNvPicPr>
+          <p:nvPr/>
+        </p:nvPicPr>
+        <p:blipFill>
+          <a:blip r:embed="rId1"/>
+          <a:stretch>
+            <a:fillRect/>
+          </a:stretch>
+        </p:blipFill>
+        <p:spPr>
+          <a:xfrm>
+            <a:off x="11091672" y="6382512"/>
+            <a:ext cx="384048" cy="384048"/>
+          </a:xfrm>
+          <a:prstGeom prst="rect">
+            <a:avLst/>
+          </a:prstGeom>
+        </p:spPr>
+      </p:pic>
+      <p:sp>
+        <p:nvSpPr>
+          <p:cNvPr id="5" name="Text 1"/>
+          <p:cNvSpPr/>
+          <p:nvPr/>
+        </p:nvSpPr>
+        <p:spPr>
+          <a:xfrm>
             <a:off x="685800" y="1371600"/>
             <a:ext cx="10789920" cy="1188720"/>
           </a:xfrm>
@@ -2819,7 +2882,7 @@
       </p:sp>
       <p:sp>
         <p:nvSpPr>
-          <p:cNvPr id="4" name="Text 1"/>
+          <p:cNvPr id="6" name="Text 2"/>
           <p:cNvSpPr/>
           <p:nvPr/>
         </p:nvSpPr>
@@ -2858,7 +2921,7 @@
       </p:sp>
       <p:sp>
         <p:nvSpPr>
-          <p:cNvPr id="5" name="Text 2"/>
+          <p:cNvPr id="7" name="Text 3"/>
           <p:cNvSpPr/>
           <p:nvPr/>
         </p:nvSpPr>
@@ -2892,7 +2955,7 @@
                 <a:ea typeface="Arial" pitchFamily="34" charset="-122"/>
                 <a:cs typeface="Arial" pitchFamily="34" charset="-120"/>
               </a:rPr>
-              <a:t>You don't have to get suspicious of everybody.</a:t>
+              <a:t>You can stay trusting,</a:t>
             </a:r>
             <a:endParaRPr lang="en-US" sz="2400" dirty="0"/>
           </a:p>
@@ -2912,7 +2975,7 @@
                 <a:ea typeface="Arial" pitchFamily="34" charset="-122"/>
                 <a:cs typeface="Arial" pitchFamily="34" charset="-120"/>
               </a:rPr>
-              <a:t>You add one step.</a:t>
+              <a:t>but add a pause.</a:t>
             </a:r>
             <a:endParaRPr lang="en-US" sz="2400" dirty="0"/>
           </a:p>
@@ -2958,6 +3021,69 @@
         </p:nvSpPr>
         <p:spPr>
           <a:xfrm>
+            <a:off x="685800" y="6400800"/>
+            <a:ext cx="5486400" cy="384048"/>
+          </a:xfrm>
+          <a:prstGeom prst="rect">
+            <a:avLst/>
+          </a:prstGeom>
+          <a:noFill/>
+          <a:ln/>
+        </p:spPr>
+        <p:txBody>
+          <a:bodyPr wrap="square" lIns="0" tIns="0" rIns="0" bIns="0" rtlCol="0" anchor="ctr"/>
+          <a:lstStyle/>
+          <a:p>
+            <a:pPr indent="0" marL="0">
+              <a:buNone/>
+            </a:pPr>
+            <a:r>
+              <a:rPr lang="en-US" sz="1200" dirty="0">
+                <a:solidFill>
+                  <a:srgbClr val="5A5A5A"/>
+                </a:solidFill>
+                <a:latin typeface="Arial" pitchFamily="34" charset="0"/>
+                <a:ea typeface="Arial" pitchFamily="34" charset="-122"/>
+                <a:cs typeface="Arial" pitchFamily="34" charset="-120"/>
+              </a:rPr>
+              <a:t>trustbutverifyproject.org</a:t>
+            </a:r>
+            <a:endParaRPr lang="en-US" sz="1200" dirty="0"/>
+          </a:p>
+        </p:txBody>
+      </p:sp>
+      <p:pic>
+        <p:nvPicPr>
+          <p:cNvPr id="4" name="Image 0" descr="/Users/brettmorrison/Claude/trustbutverify-site/build/deck-assets/qr-blue.png">    </p:cNvPr>
+          <p:cNvPicPr>
+            <a:picLocks noChangeAspect="1"/>
+          </p:cNvPicPr>
+          <p:nvPr/>
+        </p:nvPicPr>
+        <p:blipFill>
+          <a:blip r:embed="rId1"/>
+          <a:stretch>
+            <a:fillRect/>
+          </a:stretch>
+        </p:blipFill>
+        <p:spPr>
+          <a:xfrm>
+            <a:off x="11091672" y="6382512"/>
+            <a:ext cx="384048" cy="384048"/>
+          </a:xfrm>
+          <a:prstGeom prst="rect">
+            <a:avLst/>
+          </a:prstGeom>
+        </p:spPr>
+      </p:pic>
+      <p:sp>
+        <p:nvSpPr>
+          <p:cNvPr id="5" name="Text 1"/>
+          <p:cNvSpPr/>
+          <p:nvPr/>
+        </p:nvSpPr>
+        <p:spPr>
+          <a:xfrm>
             <a:off x="685800" y="502920"/>
             <a:ext cx="10789920" cy="1097280"/>
           </a:xfrm>
@@ -2991,7 +3117,7 @@
       </p:sp>
       <p:sp>
         <p:nvSpPr>
-          <p:cNvPr id="4" name="Text 1"/>
+          <p:cNvPr id="6" name="Text 2"/>
           <p:cNvSpPr/>
           <p:nvPr/>
         </p:nvSpPr>
@@ -3053,7 +3179,7 @@
       </p:sp>
       <p:sp>
         <p:nvSpPr>
-          <p:cNvPr id="5" name="Shape 2"/>
+          <p:cNvPr id="7" name="Shape 3"/>
           <p:cNvSpPr/>
           <p:nvPr/>
         </p:nvSpPr>
@@ -3073,7 +3199,7 @@
       </p:sp>
       <p:sp>
         <p:nvSpPr>
-          <p:cNvPr id="6" name="Text 3"/>
+          <p:cNvPr id="8" name="Text 4"/>
           <p:cNvSpPr/>
           <p:nvPr/>
         </p:nvSpPr>
@@ -3135,7 +3261,7 @@
       </p:sp>
       <p:sp>
         <p:nvSpPr>
-          <p:cNvPr id="7" name="Text 4"/>
+          <p:cNvPr id="9" name="Text 5"/>
           <p:cNvSpPr/>
           <p:nvPr/>
         </p:nvSpPr>
@@ -3235,6 +3361,69 @@
         </p:nvSpPr>
         <p:spPr>
           <a:xfrm>
+            <a:off x="685800" y="6400800"/>
+            <a:ext cx="5486400" cy="384048"/>
+          </a:xfrm>
+          <a:prstGeom prst="rect">
+            <a:avLst/>
+          </a:prstGeom>
+          <a:noFill/>
+          <a:ln/>
+        </p:spPr>
+        <p:txBody>
+          <a:bodyPr wrap="square" lIns="0" tIns="0" rIns="0" bIns="0" rtlCol="0" anchor="ctr"/>
+          <a:lstStyle/>
+          <a:p>
+            <a:pPr indent="0" marL="0">
+              <a:buNone/>
+            </a:pPr>
+            <a:r>
+              <a:rPr lang="en-US" sz="1200" dirty="0">
+                <a:solidFill>
+                  <a:srgbClr val="9A958C"/>
+                </a:solidFill>
+                <a:latin typeface="Arial" pitchFamily="34" charset="0"/>
+                <a:ea typeface="Arial" pitchFamily="34" charset="-122"/>
+                <a:cs typeface="Arial" pitchFamily="34" charset="-120"/>
+              </a:rPr>
+              <a:t>trustbutverifyproject.org</a:t>
+            </a:r>
+            <a:endParaRPr lang="en-US" sz="1200" dirty="0"/>
+          </a:p>
+        </p:txBody>
+      </p:sp>
+      <p:pic>
+        <p:nvPicPr>
+          <p:cNvPr id="4" name="Image 0" descr="/Users/brettmorrison/Claude/trustbutverify-site/build/deck-assets/qr-paper.png">    </p:cNvPr>
+          <p:cNvPicPr>
+            <a:picLocks noChangeAspect="1"/>
+          </p:cNvPicPr>
+          <p:nvPr/>
+        </p:nvPicPr>
+        <p:blipFill>
+          <a:blip r:embed="rId1"/>
+          <a:stretch>
+            <a:fillRect/>
+          </a:stretch>
+        </p:blipFill>
+        <p:spPr>
+          <a:xfrm>
+            <a:off x="11091672" y="6382512"/>
+            <a:ext cx="384048" cy="384048"/>
+          </a:xfrm>
+          <a:prstGeom prst="rect">
+            <a:avLst/>
+          </a:prstGeom>
+        </p:spPr>
+      </p:pic>
+      <p:sp>
+        <p:nvSpPr>
+          <p:cNvPr id="5" name="Text 1"/>
+          <p:cNvSpPr/>
+          <p:nvPr/>
+        </p:nvSpPr>
+        <p:spPr>
+          <a:xfrm>
             <a:off x="685800" y="1920240"/>
             <a:ext cx="10058400" cy="2194560"/>
           </a:xfrm>
@@ -3329,6 +3518,69 @@
         </p:nvSpPr>
         <p:spPr>
           <a:xfrm>
+            <a:off x="685800" y="6400800"/>
+            <a:ext cx="5486400" cy="384048"/>
+          </a:xfrm>
+          <a:prstGeom prst="rect">
+            <a:avLst/>
+          </a:prstGeom>
+          <a:noFill/>
+          <a:ln/>
+        </p:spPr>
+        <p:txBody>
+          <a:bodyPr wrap="square" lIns="0" tIns="0" rIns="0" bIns="0" rtlCol="0" anchor="ctr"/>
+          <a:lstStyle/>
+          <a:p>
+            <a:pPr indent="0" marL="0">
+              <a:buNone/>
+            </a:pPr>
+            <a:r>
+              <a:rPr lang="en-US" sz="1200" dirty="0">
+                <a:solidFill>
+                  <a:srgbClr val="5A5A5A"/>
+                </a:solidFill>
+                <a:latin typeface="Arial" pitchFamily="34" charset="0"/>
+                <a:ea typeface="Arial" pitchFamily="34" charset="-122"/>
+                <a:cs typeface="Arial" pitchFamily="34" charset="-120"/>
+              </a:rPr>
+              <a:t>trustbutverifyproject.org</a:t>
+            </a:r>
+            <a:endParaRPr lang="en-US" sz="1200" dirty="0"/>
+          </a:p>
+        </p:txBody>
+      </p:sp>
+      <p:pic>
+        <p:nvPicPr>
+          <p:cNvPr id="4" name="Image 0" descr="/Users/brettmorrison/Claude/trustbutverify-site/build/deck-assets/qr-blue.png">    </p:cNvPr>
+          <p:cNvPicPr>
+            <a:picLocks noChangeAspect="1"/>
+          </p:cNvPicPr>
+          <p:nvPr/>
+        </p:nvPicPr>
+        <p:blipFill>
+          <a:blip r:embed="rId1"/>
+          <a:stretch>
+            <a:fillRect/>
+          </a:stretch>
+        </p:blipFill>
+        <p:spPr>
+          <a:xfrm>
+            <a:off x="11091672" y="6382512"/>
+            <a:ext cx="384048" cy="384048"/>
+          </a:xfrm>
+          <a:prstGeom prst="rect">
+            <a:avLst/>
+          </a:prstGeom>
+        </p:spPr>
+      </p:pic>
+      <p:sp>
+        <p:nvSpPr>
+          <p:cNvPr id="5" name="Text 1"/>
+          <p:cNvSpPr/>
+          <p:nvPr/>
+        </p:nvSpPr>
+        <p:spPr>
+          <a:xfrm>
             <a:off x="685800" y="502920"/>
             <a:ext cx="10789920" cy="1097280"/>
           </a:xfrm>
@@ -3362,7 +3614,7 @@
       </p:sp>
       <p:sp>
         <p:nvSpPr>
-          <p:cNvPr id="4" name="Text 1"/>
+          <p:cNvPr id="6" name="Text 2"/>
           <p:cNvSpPr/>
           <p:nvPr/>
         </p:nvSpPr>
@@ -3401,7 +3653,7 @@
       </p:sp>
       <p:sp>
         <p:nvSpPr>
-          <p:cNvPr id="5" name="Text 2"/>
+          <p:cNvPr id="7" name="Text 3"/>
           <p:cNvSpPr/>
           <p:nvPr/>
         </p:nvSpPr>
@@ -3440,7 +3692,7 @@
       </p:sp>
       <p:sp>
         <p:nvSpPr>
-          <p:cNvPr id="6" name="Text 3"/>
+          <p:cNvPr id="8" name="Text 4"/>
           <p:cNvSpPr/>
           <p:nvPr/>
         </p:nvSpPr>
@@ -3479,7 +3731,7 @@
       </p:sp>
       <p:sp>
         <p:nvSpPr>
-          <p:cNvPr id="7" name="Text 4"/>
+          <p:cNvPr id="9" name="Text 5"/>
           <p:cNvSpPr/>
           <p:nvPr/>
         </p:nvSpPr>
@@ -3518,7 +3770,7 @@
       </p:sp>
       <p:sp>
         <p:nvSpPr>
-          <p:cNvPr id="8" name="Text 5"/>
+          <p:cNvPr id="10" name="Text 6"/>
           <p:cNvSpPr/>
           <p:nvPr/>
         </p:nvSpPr>
@@ -3557,7 +3809,7 @@
       </p:sp>
       <p:sp>
         <p:nvSpPr>
-          <p:cNvPr id="9" name="Text 6"/>
+          <p:cNvPr id="11" name="Text 7"/>
           <p:cNvSpPr/>
           <p:nvPr/>
         </p:nvSpPr>
@@ -3596,7 +3848,7 @@
       </p:sp>
       <p:sp>
         <p:nvSpPr>
-          <p:cNvPr id="10" name="Text 7"/>
+          <p:cNvPr id="12" name="Text 8"/>
           <p:cNvSpPr/>
           <p:nvPr/>
         </p:nvSpPr>
@@ -3635,7 +3887,7 @@
       </p:sp>
       <p:sp>
         <p:nvSpPr>
-          <p:cNvPr id="11" name="Text 8"/>
+          <p:cNvPr id="13" name="Text 9"/>
           <p:cNvSpPr/>
           <p:nvPr/>
         </p:nvSpPr>
@@ -3674,7 +3926,7 @@
       </p:sp>
       <p:sp>
         <p:nvSpPr>
-          <p:cNvPr id="12" name="Text 9"/>
+          <p:cNvPr id="14" name="Text 10"/>
           <p:cNvSpPr/>
           <p:nvPr/>
         </p:nvSpPr>
@@ -3713,7 +3965,7 @@
       </p:sp>
       <p:sp>
         <p:nvSpPr>
-          <p:cNvPr id="13" name="Text 10"/>
+          <p:cNvPr id="15" name="Text 11"/>
           <p:cNvSpPr/>
           <p:nvPr/>
         </p:nvSpPr>
@@ -3790,6 +4042,69 @@
         </p:nvSpPr>
         <p:spPr>
           <a:xfrm>
+            <a:off x="685800" y="6400800"/>
+            <a:ext cx="5486400" cy="384048"/>
+          </a:xfrm>
+          <a:prstGeom prst="rect">
+            <a:avLst/>
+          </a:prstGeom>
+          <a:noFill/>
+          <a:ln/>
+        </p:spPr>
+        <p:txBody>
+          <a:bodyPr wrap="square" lIns="0" tIns="0" rIns="0" bIns="0" rtlCol="0" anchor="ctr"/>
+          <a:lstStyle/>
+          <a:p>
+            <a:pPr indent="0" marL="0">
+              <a:buNone/>
+            </a:pPr>
+            <a:r>
+              <a:rPr lang="en-US" sz="1200" dirty="0">
+                <a:solidFill>
+                  <a:srgbClr val="9A958C"/>
+                </a:solidFill>
+                <a:latin typeface="Arial" pitchFamily="34" charset="0"/>
+                <a:ea typeface="Arial" pitchFamily="34" charset="-122"/>
+                <a:cs typeface="Arial" pitchFamily="34" charset="-120"/>
+              </a:rPr>
+              <a:t>trustbutverifyproject.org</a:t>
+            </a:r>
+            <a:endParaRPr lang="en-US" sz="1200" dirty="0"/>
+          </a:p>
+        </p:txBody>
+      </p:sp>
+      <p:pic>
+        <p:nvPicPr>
+          <p:cNvPr id="4" name="Image 0" descr="/Users/brettmorrison/Claude/trustbutverify-site/build/deck-assets/qr-paper.png">    </p:cNvPr>
+          <p:cNvPicPr>
+            <a:picLocks noChangeAspect="1"/>
+          </p:cNvPicPr>
+          <p:nvPr/>
+        </p:nvPicPr>
+        <p:blipFill>
+          <a:blip r:embed="rId1"/>
+          <a:stretch>
+            <a:fillRect/>
+          </a:stretch>
+        </p:blipFill>
+        <p:spPr>
+          <a:xfrm>
+            <a:off x="11091672" y="6382512"/>
+            <a:ext cx="384048" cy="384048"/>
+          </a:xfrm>
+          <a:prstGeom prst="rect">
+            <a:avLst/>
+          </a:prstGeom>
+        </p:spPr>
+      </p:pic>
+      <p:sp>
+        <p:nvSpPr>
+          <p:cNvPr id="5" name="Text 1"/>
+          <p:cNvSpPr/>
+          <p:nvPr/>
+        </p:nvSpPr>
+        <p:spPr>
+          <a:xfrm>
             <a:off x="685800" y="1920240"/>
             <a:ext cx="10515600" cy="2194560"/>
           </a:xfrm>
@@ -3878,7 +4193,70 @@
       </p:grpSpPr>
       <p:sp>
         <p:nvSpPr>
-          <p:cNvPr id="3" name="Shape 0"/>
+          <p:cNvPr id="3" name="Text 0"/>
+          <p:cNvSpPr/>
+          <p:nvPr/>
+        </p:nvSpPr>
+        <p:spPr>
+          <a:xfrm>
+            <a:off x="685800" y="6400800"/>
+            <a:ext cx="5486400" cy="384048"/>
+          </a:xfrm>
+          <a:prstGeom prst="rect">
+            <a:avLst/>
+          </a:prstGeom>
+          <a:noFill/>
+          <a:ln/>
+        </p:spPr>
+        <p:txBody>
+          <a:bodyPr wrap="square" lIns="0" tIns="0" rIns="0" bIns="0" rtlCol="0" anchor="ctr"/>
+          <a:lstStyle/>
+          <a:p>
+            <a:pPr indent="0" marL="0">
+              <a:buNone/>
+            </a:pPr>
+            <a:r>
+              <a:rPr lang="en-US" sz="1200" dirty="0">
+                <a:solidFill>
+                  <a:srgbClr val="5A5A5A"/>
+                </a:solidFill>
+                <a:latin typeface="Arial" pitchFamily="34" charset="0"/>
+                <a:ea typeface="Arial" pitchFamily="34" charset="-122"/>
+                <a:cs typeface="Arial" pitchFamily="34" charset="-120"/>
+              </a:rPr>
+              <a:t>trustbutverifyproject.org</a:t>
+            </a:r>
+            <a:endParaRPr lang="en-US" sz="1200" dirty="0"/>
+          </a:p>
+        </p:txBody>
+      </p:sp>
+      <p:pic>
+        <p:nvPicPr>
+          <p:cNvPr id="4" name="Image 0" descr="/Users/brettmorrison/Claude/trustbutverify-site/build/deck-assets/qr-blue.png">    </p:cNvPr>
+          <p:cNvPicPr>
+            <a:picLocks noChangeAspect="1"/>
+          </p:cNvPicPr>
+          <p:nvPr/>
+        </p:nvPicPr>
+        <p:blipFill>
+          <a:blip r:embed="rId1"/>
+          <a:stretch>
+            <a:fillRect/>
+          </a:stretch>
+        </p:blipFill>
+        <p:spPr>
+          <a:xfrm>
+            <a:off x="11091672" y="6382512"/>
+            <a:ext cx="384048" cy="384048"/>
+          </a:xfrm>
+          <a:prstGeom prst="rect">
+            <a:avLst/>
+          </a:prstGeom>
+        </p:spPr>
+      </p:pic>
+      <p:sp>
+        <p:nvSpPr>
+          <p:cNvPr id="5" name="Shape 1"/>
           <p:cNvSpPr/>
           <p:nvPr/>
         </p:nvSpPr>
@@ -3903,7 +4281,7 @@
       </p:sp>
       <p:sp>
         <p:nvSpPr>
-          <p:cNvPr id="4" name="Text 1"/>
+          <p:cNvPr id="6" name="Text 2"/>
           <p:cNvSpPr/>
           <p:nvPr/>
         </p:nvSpPr>
@@ -3965,7 +4343,7 @@
       </p:sp>
       <p:sp>
         <p:nvSpPr>
-          <p:cNvPr id="5" name="Text 2"/>
+          <p:cNvPr id="7" name="Text 3"/>
           <p:cNvSpPr/>
           <p:nvPr/>
         </p:nvSpPr>
@@ -4088,7 +4466,70 @@
       </p:grpSpPr>
       <p:sp>
         <p:nvSpPr>
-          <p:cNvPr id="3" name="Shape 0"/>
+          <p:cNvPr id="3" name="Text 0"/>
+          <p:cNvSpPr/>
+          <p:nvPr/>
+        </p:nvSpPr>
+        <p:spPr>
+          <a:xfrm>
+            <a:off x="685800" y="6400800"/>
+            <a:ext cx="5486400" cy="384048"/>
+          </a:xfrm>
+          <a:prstGeom prst="rect">
+            <a:avLst/>
+          </a:prstGeom>
+          <a:noFill/>
+          <a:ln/>
+        </p:spPr>
+        <p:txBody>
+          <a:bodyPr wrap="square" lIns="0" tIns="0" rIns="0" bIns="0" rtlCol="0" anchor="ctr"/>
+          <a:lstStyle/>
+          <a:p>
+            <a:pPr indent="0" marL="0">
+              <a:buNone/>
+            </a:pPr>
+            <a:r>
+              <a:rPr lang="en-US" sz="1200" dirty="0">
+                <a:solidFill>
+                  <a:srgbClr val="5A5A5A"/>
+                </a:solidFill>
+                <a:latin typeface="Arial" pitchFamily="34" charset="0"/>
+                <a:ea typeface="Arial" pitchFamily="34" charset="-122"/>
+                <a:cs typeface="Arial" pitchFamily="34" charset="-120"/>
+              </a:rPr>
+              <a:t>trustbutverifyproject.org</a:t>
+            </a:r>
+            <a:endParaRPr lang="en-US" sz="1200" dirty="0"/>
+          </a:p>
+        </p:txBody>
+      </p:sp>
+      <p:pic>
+        <p:nvPicPr>
+          <p:cNvPr id="4" name="Image 0" descr="/Users/brettmorrison/Claude/trustbutverify-site/build/deck-assets/qr-blue.png">    </p:cNvPr>
+          <p:cNvPicPr>
+            <a:picLocks noChangeAspect="1"/>
+          </p:cNvPicPr>
+          <p:nvPr/>
+        </p:nvPicPr>
+        <p:blipFill>
+          <a:blip r:embed="rId1"/>
+          <a:stretch>
+            <a:fillRect/>
+          </a:stretch>
+        </p:blipFill>
+        <p:spPr>
+          <a:xfrm>
+            <a:off x="11091672" y="6382512"/>
+            <a:ext cx="384048" cy="384048"/>
+          </a:xfrm>
+          <a:prstGeom prst="rect">
+            <a:avLst/>
+          </a:prstGeom>
+        </p:spPr>
+      </p:pic>
+      <p:sp>
+        <p:nvSpPr>
+          <p:cNvPr id="5" name="Shape 1"/>
           <p:cNvSpPr/>
           <p:nvPr/>
         </p:nvSpPr>
@@ -4113,7 +4554,7 @@
       </p:sp>
       <p:sp>
         <p:nvSpPr>
-          <p:cNvPr id="4" name="Text 1"/>
+          <p:cNvPr id="6" name="Text 2"/>
           <p:cNvSpPr/>
           <p:nvPr/>
         </p:nvSpPr>
@@ -4175,7 +4616,7 @@
       </p:sp>
       <p:sp>
         <p:nvSpPr>
-          <p:cNvPr id="5" name="Text 2"/>
+          <p:cNvPr id="7" name="Text 3"/>
           <p:cNvSpPr/>
           <p:nvPr/>
         </p:nvSpPr>
@@ -4304,6 +4745,69 @@
         </p:nvSpPr>
         <p:spPr>
           <a:xfrm>
+            <a:off x="685800" y="6400800"/>
+            <a:ext cx="5486400" cy="384048"/>
+          </a:xfrm>
+          <a:prstGeom prst="rect">
+            <a:avLst/>
+          </a:prstGeom>
+          <a:noFill/>
+          <a:ln/>
+        </p:spPr>
+        <p:txBody>
+          <a:bodyPr wrap="square" lIns="0" tIns="0" rIns="0" bIns="0" rtlCol="0" anchor="ctr"/>
+          <a:lstStyle/>
+          <a:p>
+            <a:pPr indent="0" marL="0">
+              <a:buNone/>
+            </a:pPr>
+            <a:r>
+              <a:rPr lang="en-US" sz="1200" dirty="0">
+                <a:solidFill>
+                  <a:srgbClr val="5A5A5A"/>
+                </a:solidFill>
+                <a:latin typeface="Arial" pitchFamily="34" charset="0"/>
+                <a:ea typeface="Arial" pitchFamily="34" charset="-122"/>
+                <a:cs typeface="Arial" pitchFamily="34" charset="-120"/>
+              </a:rPr>
+              <a:t>trustbutverifyproject.org</a:t>
+            </a:r>
+            <a:endParaRPr lang="en-US" sz="1200" dirty="0"/>
+          </a:p>
+        </p:txBody>
+      </p:sp>
+      <p:pic>
+        <p:nvPicPr>
+          <p:cNvPr id="4" name="Image 0" descr="/Users/brettmorrison/Claude/trustbutverify-site/build/deck-assets/qr-blue.png">    </p:cNvPr>
+          <p:cNvPicPr>
+            <a:picLocks noChangeAspect="1"/>
+          </p:cNvPicPr>
+          <p:nvPr/>
+        </p:nvPicPr>
+        <p:blipFill>
+          <a:blip r:embed="rId1"/>
+          <a:stretch>
+            <a:fillRect/>
+          </a:stretch>
+        </p:blipFill>
+        <p:spPr>
+          <a:xfrm>
+            <a:off x="11091672" y="6382512"/>
+            <a:ext cx="384048" cy="384048"/>
+          </a:xfrm>
+          <a:prstGeom prst="rect">
+            <a:avLst/>
+          </a:prstGeom>
+        </p:spPr>
+      </p:pic>
+      <p:sp>
+        <p:nvSpPr>
+          <p:cNvPr id="5" name="Text 1"/>
+          <p:cNvSpPr/>
+          <p:nvPr/>
+        </p:nvSpPr>
+        <p:spPr>
+          <a:xfrm>
             <a:off x="685800" y="502920"/>
             <a:ext cx="10789920" cy="1097280"/>
           </a:xfrm>
@@ -4337,7 +4841,7 @@
       </p:sp>
       <p:sp>
         <p:nvSpPr>
-          <p:cNvPr id="4" name="Text 1"/>
+          <p:cNvPr id="6" name="Text 2"/>
           <p:cNvSpPr/>
           <p:nvPr/>
         </p:nvSpPr>
@@ -4376,7 +4880,7 @@
       </p:sp>
       <p:sp>
         <p:nvSpPr>
-          <p:cNvPr id="5" name="Shape 2"/>
+          <p:cNvPr id="7" name="Shape 3"/>
           <p:cNvSpPr/>
           <p:nvPr/>
         </p:nvSpPr>
@@ -4396,7 +4900,7 @@
       </p:sp>
       <p:sp>
         <p:nvSpPr>
-          <p:cNvPr id="6" name="Text 3"/>
+          <p:cNvPr id="8" name="Text 4"/>
           <p:cNvSpPr/>
           <p:nvPr/>
         </p:nvSpPr>
@@ -4435,7 +4939,7 @@
       </p:sp>
       <p:sp>
         <p:nvSpPr>
-          <p:cNvPr id="7" name="Text 4"/>
+          <p:cNvPr id="9" name="Text 5"/>
           <p:cNvSpPr/>
           <p:nvPr/>
         </p:nvSpPr>
@@ -4474,7 +4978,7 @@
       </p:sp>
       <p:sp>
         <p:nvSpPr>
-          <p:cNvPr id="8" name="Shape 5"/>
+          <p:cNvPr id="10" name="Shape 6"/>
           <p:cNvSpPr/>
           <p:nvPr/>
         </p:nvSpPr>
@@ -4494,7 +4998,7 @@
       </p:sp>
       <p:sp>
         <p:nvSpPr>
-          <p:cNvPr id="9" name="Text 6"/>
+          <p:cNvPr id="11" name="Text 7"/>
           <p:cNvSpPr/>
           <p:nvPr/>
         </p:nvSpPr>
@@ -4533,7 +5037,7 @@
       </p:sp>
       <p:sp>
         <p:nvSpPr>
-          <p:cNvPr id="10" name="Text 7"/>
+          <p:cNvPr id="12" name="Text 8"/>
           <p:cNvSpPr/>
           <p:nvPr/>
         </p:nvSpPr>
@@ -4572,7 +5076,7 @@
       </p:sp>
       <p:sp>
         <p:nvSpPr>
-          <p:cNvPr id="11" name="Shape 8"/>
+          <p:cNvPr id="13" name="Shape 9"/>
           <p:cNvSpPr/>
           <p:nvPr/>
         </p:nvSpPr>
@@ -4592,7 +5096,7 @@
       </p:sp>
       <p:sp>
         <p:nvSpPr>
-          <p:cNvPr id="12" name="Text 9"/>
+          <p:cNvPr id="14" name="Text 10"/>
           <p:cNvSpPr/>
           <p:nvPr/>
         </p:nvSpPr>
@@ -4631,7 +5135,7 @@
       </p:sp>
       <p:sp>
         <p:nvSpPr>
-          <p:cNvPr id="13" name="Text 10"/>
+          <p:cNvPr id="15" name="Text 11"/>
           <p:cNvSpPr/>
           <p:nvPr/>
         </p:nvSpPr>
@@ -4670,7 +5174,7 @@
       </p:sp>
       <p:sp>
         <p:nvSpPr>
-          <p:cNvPr id="14" name="Shape 11"/>
+          <p:cNvPr id="16" name="Shape 12"/>
           <p:cNvSpPr/>
           <p:nvPr/>
         </p:nvSpPr>
@@ -4690,7 +5194,7 @@
       </p:sp>
       <p:sp>
         <p:nvSpPr>
-          <p:cNvPr id="15" name="Text 12"/>
+          <p:cNvPr id="17" name="Text 13"/>
           <p:cNvSpPr/>
           <p:nvPr/>
         </p:nvSpPr>
@@ -4729,7 +5233,7 @@
       </p:sp>
       <p:sp>
         <p:nvSpPr>
-          <p:cNvPr id="16" name="Text 13"/>
+          <p:cNvPr id="18" name="Text 14"/>
           <p:cNvSpPr/>
           <p:nvPr/>
         </p:nvSpPr>
@@ -4768,7 +5272,7 @@
       </p:sp>
       <p:sp>
         <p:nvSpPr>
-          <p:cNvPr id="17" name="Shape 14"/>
+          <p:cNvPr id="19" name="Shape 15"/>
           <p:cNvSpPr/>
           <p:nvPr/>
         </p:nvSpPr>
@@ -4788,7 +5292,7 @@
       </p:sp>
       <p:sp>
         <p:nvSpPr>
-          <p:cNvPr id="18" name="Text 15"/>
+          <p:cNvPr id="20" name="Text 16"/>
           <p:cNvSpPr/>
           <p:nvPr/>
         </p:nvSpPr>
@@ -4827,7 +5331,7 @@
       </p:sp>
       <p:sp>
         <p:nvSpPr>
-          <p:cNvPr id="19" name="Text 16"/>
+          <p:cNvPr id="21" name="Text 17"/>
           <p:cNvSpPr/>
           <p:nvPr/>
         </p:nvSpPr>
@@ -4866,7 +5370,7 @@
       </p:sp>
       <p:sp>
         <p:nvSpPr>
-          <p:cNvPr id="20" name="Shape 17"/>
+          <p:cNvPr id="22" name="Shape 18"/>
           <p:cNvSpPr/>
           <p:nvPr/>
         </p:nvSpPr>
@@ -4886,7 +5390,7 @@
       </p:sp>
       <p:sp>
         <p:nvSpPr>
-          <p:cNvPr id="21" name="Text 18"/>
+          <p:cNvPr id="23" name="Text 19"/>
           <p:cNvSpPr/>
           <p:nvPr/>
         </p:nvSpPr>
@@ -4925,7 +5429,7 @@
       </p:sp>
       <p:sp>
         <p:nvSpPr>
-          <p:cNvPr id="22" name="Text 19"/>
+          <p:cNvPr id="24" name="Text 20"/>
           <p:cNvSpPr/>
           <p:nvPr/>
         </p:nvSpPr>
@@ -4964,7 +5468,7 @@
       </p:sp>
       <p:sp>
         <p:nvSpPr>
-          <p:cNvPr id="23" name="Text 20"/>
+          <p:cNvPr id="25" name="Text 21"/>
           <p:cNvSpPr/>
           <p:nvPr/>
         </p:nvSpPr>
@@ -5041,6 +5545,69 @@
         </p:nvSpPr>
         <p:spPr>
           <a:xfrm>
+            <a:off x="685800" y="6400800"/>
+            <a:ext cx="5486400" cy="384048"/>
+          </a:xfrm>
+          <a:prstGeom prst="rect">
+            <a:avLst/>
+          </a:prstGeom>
+          <a:noFill/>
+          <a:ln/>
+        </p:spPr>
+        <p:txBody>
+          <a:bodyPr wrap="square" lIns="0" tIns="0" rIns="0" bIns="0" rtlCol="0" anchor="ctr"/>
+          <a:lstStyle/>
+          <a:p>
+            <a:pPr indent="0" marL="0">
+              <a:buNone/>
+            </a:pPr>
+            <a:r>
+              <a:rPr lang="en-US" sz="1200" dirty="0">
+                <a:solidFill>
+                  <a:srgbClr val="9A958C"/>
+                </a:solidFill>
+                <a:latin typeface="Arial" pitchFamily="34" charset="0"/>
+                <a:ea typeface="Arial" pitchFamily="34" charset="-122"/>
+                <a:cs typeface="Arial" pitchFamily="34" charset="-120"/>
+              </a:rPr>
+              <a:t>trustbutverifyproject.org</a:t>
+            </a:r>
+            <a:endParaRPr lang="en-US" sz="1200" dirty="0"/>
+          </a:p>
+        </p:txBody>
+      </p:sp>
+      <p:pic>
+        <p:nvPicPr>
+          <p:cNvPr id="4" name="Image 0" descr="/Users/brettmorrison/Claude/trustbutverify-site/build/deck-assets/qr-paper.png">    </p:cNvPr>
+          <p:cNvPicPr>
+            <a:picLocks noChangeAspect="1"/>
+          </p:cNvPicPr>
+          <p:nvPr/>
+        </p:nvPicPr>
+        <p:blipFill>
+          <a:blip r:embed="rId1"/>
+          <a:stretch>
+            <a:fillRect/>
+          </a:stretch>
+        </p:blipFill>
+        <p:spPr>
+          <a:xfrm>
+            <a:off x="11091672" y="6382512"/>
+            <a:ext cx="384048" cy="384048"/>
+          </a:xfrm>
+          <a:prstGeom prst="rect">
+            <a:avLst/>
+          </a:prstGeom>
+        </p:spPr>
+      </p:pic>
+      <p:sp>
+        <p:nvSpPr>
+          <p:cNvPr id="5" name="Text 1"/>
+          <p:cNvSpPr/>
+          <p:nvPr/>
+        </p:nvSpPr>
+        <p:spPr>
+          <a:xfrm>
             <a:off x="685800" y="1920240"/>
             <a:ext cx="10058400" cy="2194560"/>
           </a:xfrm>
@@ -5135,6 +5702,69 @@
         </p:nvSpPr>
         <p:spPr>
           <a:xfrm>
+            <a:off x="685800" y="6400800"/>
+            <a:ext cx="5486400" cy="384048"/>
+          </a:xfrm>
+          <a:prstGeom prst="rect">
+            <a:avLst/>
+          </a:prstGeom>
+          <a:noFill/>
+          <a:ln/>
+        </p:spPr>
+        <p:txBody>
+          <a:bodyPr wrap="square" lIns="0" tIns="0" rIns="0" bIns="0" rtlCol="0" anchor="ctr"/>
+          <a:lstStyle/>
+          <a:p>
+            <a:pPr indent="0" marL="0">
+              <a:buNone/>
+            </a:pPr>
+            <a:r>
+              <a:rPr lang="en-US" sz="1200" dirty="0">
+                <a:solidFill>
+                  <a:srgbClr val="5A5A5A"/>
+                </a:solidFill>
+                <a:latin typeface="Arial" pitchFamily="34" charset="0"/>
+                <a:ea typeface="Arial" pitchFamily="34" charset="-122"/>
+                <a:cs typeface="Arial" pitchFamily="34" charset="-120"/>
+              </a:rPr>
+              <a:t>trustbutverifyproject.org</a:t>
+            </a:r>
+            <a:endParaRPr lang="en-US" sz="1200" dirty="0"/>
+          </a:p>
+        </p:txBody>
+      </p:sp>
+      <p:pic>
+        <p:nvPicPr>
+          <p:cNvPr id="4" name="Image 0" descr="/Users/brettmorrison/Claude/trustbutverify-site/build/deck-assets/qr-blue.png">    </p:cNvPr>
+          <p:cNvPicPr>
+            <a:picLocks noChangeAspect="1"/>
+          </p:cNvPicPr>
+          <p:nvPr/>
+        </p:nvPicPr>
+        <p:blipFill>
+          <a:blip r:embed="rId1"/>
+          <a:stretch>
+            <a:fillRect/>
+          </a:stretch>
+        </p:blipFill>
+        <p:spPr>
+          <a:xfrm>
+            <a:off x="11091672" y="6382512"/>
+            <a:ext cx="384048" cy="384048"/>
+          </a:xfrm>
+          <a:prstGeom prst="rect">
+            <a:avLst/>
+          </a:prstGeom>
+        </p:spPr>
+      </p:pic>
+      <p:sp>
+        <p:nvSpPr>
+          <p:cNvPr id="5" name="Text 1"/>
+          <p:cNvSpPr/>
+          <p:nvPr/>
+        </p:nvSpPr>
+        <p:spPr>
+          <a:xfrm>
             <a:off x="685800" y="502920"/>
             <a:ext cx="10789920" cy="1097280"/>
           </a:xfrm>
@@ -5168,7 +5798,7 @@
       </p:sp>
       <p:sp>
         <p:nvSpPr>
-          <p:cNvPr id="4" name="Text 1"/>
+          <p:cNvPr id="6" name="Text 2"/>
           <p:cNvSpPr/>
           <p:nvPr/>
         </p:nvSpPr>
@@ -5230,7 +5860,7 @@
       </p:sp>
       <p:sp>
         <p:nvSpPr>
-          <p:cNvPr id="5" name="Shape 2"/>
+          <p:cNvPr id="7" name="Shape 3"/>
           <p:cNvSpPr/>
           <p:nvPr/>
         </p:nvSpPr>
@@ -5250,7 +5880,7 @@
       </p:sp>
       <p:sp>
         <p:nvSpPr>
-          <p:cNvPr id="6" name="Text 3"/>
+          <p:cNvPr id="8" name="Text 4"/>
           <p:cNvSpPr/>
           <p:nvPr/>
         </p:nvSpPr>
@@ -5289,7 +5919,7 @@
       </p:sp>
       <p:sp>
         <p:nvSpPr>
-          <p:cNvPr id="7" name="Text 4"/>
+          <p:cNvPr id="9" name="Text 5"/>
           <p:cNvSpPr/>
           <p:nvPr/>
         </p:nvSpPr>
@@ -5328,7 +5958,7 @@
       </p:sp>
       <p:sp>
         <p:nvSpPr>
-          <p:cNvPr id="8" name="Text 5"/>
+          <p:cNvPr id="10" name="Text 6"/>
           <p:cNvSpPr/>
           <p:nvPr/>
         </p:nvSpPr>
@@ -5367,7 +5997,7 @@
       </p:sp>
       <p:sp>
         <p:nvSpPr>
-          <p:cNvPr id="9" name="Shape 6"/>
+          <p:cNvPr id="11" name="Shape 7"/>
           <p:cNvSpPr/>
           <p:nvPr/>
         </p:nvSpPr>
@@ -5387,7 +6017,7 @@
       </p:sp>
       <p:sp>
         <p:nvSpPr>
-          <p:cNvPr id="10" name="Text 7"/>
+          <p:cNvPr id="12" name="Text 8"/>
           <p:cNvSpPr/>
           <p:nvPr/>
         </p:nvSpPr>
@@ -5426,7 +6056,7 @@
       </p:sp>
       <p:sp>
         <p:nvSpPr>
-          <p:cNvPr id="11" name="Text 8"/>
+          <p:cNvPr id="13" name="Text 9"/>
           <p:cNvSpPr/>
           <p:nvPr/>
         </p:nvSpPr>
@@ -5465,7 +6095,7 @@
       </p:sp>
       <p:sp>
         <p:nvSpPr>
-          <p:cNvPr id="12" name="Text 9"/>
+          <p:cNvPr id="14" name="Text 10"/>
           <p:cNvSpPr/>
           <p:nvPr/>
         </p:nvSpPr>
@@ -5504,7 +6134,7 @@
       </p:sp>
       <p:sp>
         <p:nvSpPr>
-          <p:cNvPr id="13" name="Shape 10"/>
+          <p:cNvPr id="15" name="Shape 11"/>
           <p:cNvSpPr/>
           <p:nvPr/>
         </p:nvSpPr>
@@ -5524,7 +6154,7 @@
       </p:sp>
       <p:sp>
         <p:nvSpPr>
-          <p:cNvPr id="14" name="Text 11"/>
+          <p:cNvPr id="16" name="Text 12"/>
           <p:cNvSpPr/>
           <p:nvPr/>
         </p:nvSpPr>
@@ -5563,7 +6193,7 @@
       </p:sp>
       <p:sp>
         <p:nvSpPr>
-          <p:cNvPr id="15" name="Text 12"/>
+          <p:cNvPr id="17" name="Text 13"/>
           <p:cNvSpPr/>
           <p:nvPr/>
         </p:nvSpPr>
@@ -5602,7 +6232,7 @@
       </p:sp>
       <p:sp>
         <p:nvSpPr>
-          <p:cNvPr id="16" name="Text 13"/>
+          <p:cNvPr id="18" name="Text 14"/>
           <p:cNvSpPr/>
           <p:nvPr/>
         </p:nvSpPr>
@@ -5679,6 +6309,69 @@
         </p:nvSpPr>
         <p:spPr>
           <a:xfrm>
+            <a:off x="685800" y="6400800"/>
+            <a:ext cx="5486400" cy="384048"/>
+          </a:xfrm>
+          <a:prstGeom prst="rect">
+            <a:avLst/>
+          </a:prstGeom>
+          <a:noFill/>
+          <a:ln/>
+        </p:spPr>
+        <p:txBody>
+          <a:bodyPr wrap="square" lIns="0" tIns="0" rIns="0" bIns="0" rtlCol="0" anchor="ctr"/>
+          <a:lstStyle/>
+          <a:p>
+            <a:pPr indent="0" marL="0">
+              <a:buNone/>
+            </a:pPr>
+            <a:r>
+              <a:rPr lang="en-US" sz="1200" dirty="0">
+                <a:solidFill>
+                  <a:srgbClr val="5A5A5A"/>
+                </a:solidFill>
+                <a:latin typeface="Arial" pitchFamily="34" charset="0"/>
+                <a:ea typeface="Arial" pitchFamily="34" charset="-122"/>
+                <a:cs typeface="Arial" pitchFamily="34" charset="-120"/>
+              </a:rPr>
+              <a:t>trustbutverifyproject.org</a:t>
+            </a:r>
+            <a:endParaRPr lang="en-US" sz="1200" dirty="0"/>
+          </a:p>
+        </p:txBody>
+      </p:sp>
+      <p:pic>
+        <p:nvPicPr>
+          <p:cNvPr id="4" name="Image 0" descr="/Users/brettmorrison/Claude/trustbutverify-site/build/deck-assets/qr-blue.png">    </p:cNvPr>
+          <p:cNvPicPr>
+            <a:picLocks noChangeAspect="1"/>
+          </p:cNvPicPr>
+          <p:nvPr/>
+        </p:nvPicPr>
+        <p:blipFill>
+          <a:blip r:embed="rId1"/>
+          <a:stretch>
+            <a:fillRect/>
+          </a:stretch>
+        </p:blipFill>
+        <p:spPr>
+          <a:xfrm>
+            <a:off x="11091672" y="6382512"/>
+            <a:ext cx="384048" cy="384048"/>
+          </a:xfrm>
+          <a:prstGeom prst="rect">
+            <a:avLst/>
+          </a:prstGeom>
+        </p:spPr>
+      </p:pic>
+      <p:sp>
+        <p:nvSpPr>
+          <p:cNvPr id="5" name="Text 1"/>
+          <p:cNvSpPr/>
+          <p:nvPr/>
+        </p:nvSpPr>
+        <p:spPr>
+          <a:xfrm>
             <a:off x="685800" y="502920"/>
             <a:ext cx="10789920" cy="1097280"/>
           </a:xfrm>
@@ -5712,7 +6405,7 @@
       </p:sp>
       <p:sp>
         <p:nvSpPr>
-          <p:cNvPr id="4" name="Text 1"/>
+          <p:cNvPr id="6" name="Text 2"/>
           <p:cNvSpPr/>
           <p:nvPr/>
         </p:nvSpPr>
@@ -5751,7 +6444,7 @@
       </p:sp>
       <p:sp>
         <p:nvSpPr>
-          <p:cNvPr id="5" name="Text 2"/>
+          <p:cNvPr id="7" name="Text 3"/>
           <p:cNvSpPr/>
           <p:nvPr/>
         </p:nvSpPr>
@@ -5790,7 +6483,7 @@
       </p:sp>
       <p:sp>
         <p:nvSpPr>
-          <p:cNvPr id="6" name="Text 3"/>
+          <p:cNvPr id="8" name="Text 4"/>
           <p:cNvSpPr/>
           <p:nvPr/>
         </p:nvSpPr>
@@ -5829,7 +6522,7 @@
       </p:sp>
       <p:sp>
         <p:nvSpPr>
-          <p:cNvPr id="7" name="Text 4"/>
+          <p:cNvPr id="9" name="Text 5"/>
           <p:cNvSpPr/>
           <p:nvPr/>
         </p:nvSpPr>
@@ -5868,7 +6561,7 @@
       </p:sp>
       <p:sp>
         <p:nvSpPr>
-          <p:cNvPr id="8" name="Text 5"/>
+          <p:cNvPr id="10" name="Text 6"/>
           <p:cNvSpPr/>
           <p:nvPr/>
         </p:nvSpPr>
@@ -5907,7 +6600,7 @@
       </p:sp>
       <p:sp>
         <p:nvSpPr>
-          <p:cNvPr id="9" name="Text 6"/>
+          <p:cNvPr id="11" name="Text 7"/>
           <p:cNvSpPr/>
           <p:nvPr/>
         </p:nvSpPr>
@@ -5946,7 +6639,7 @@
       </p:sp>
       <p:sp>
         <p:nvSpPr>
-          <p:cNvPr id="10" name="Text 7"/>
+          <p:cNvPr id="12" name="Text 8"/>
           <p:cNvSpPr/>
           <p:nvPr/>
         </p:nvSpPr>
@@ -6046,6 +6739,69 @@
         </p:nvSpPr>
         <p:spPr>
           <a:xfrm>
+            <a:off x="685800" y="6400800"/>
+            <a:ext cx="5486400" cy="384048"/>
+          </a:xfrm>
+          <a:prstGeom prst="rect">
+            <a:avLst/>
+          </a:prstGeom>
+          <a:noFill/>
+          <a:ln/>
+        </p:spPr>
+        <p:txBody>
+          <a:bodyPr wrap="square" lIns="0" tIns="0" rIns="0" bIns="0" rtlCol="0" anchor="ctr"/>
+          <a:lstStyle/>
+          <a:p>
+            <a:pPr indent="0" marL="0">
+              <a:buNone/>
+            </a:pPr>
+            <a:r>
+              <a:rPr lang="en-US" sz="1200" dirty="0">
+                <a:solidFill>
+                  <a:srgbClr val="9A958C"/>
+                </a:solidFill>
+                <a:latin typeface="Arial" pitchFamily="34" charset="0"/>
+                <a:ea typeface="Arial" pitchFamily="34" charset="-122"/>
+                <a:cs typeface="Arial" pitchFamily="34" charset="-120"/>
+              </a:rPr>
+              <a:t>trustbutverifyproject.org</a:t>
+            </a:r>
+            <a:endParaRPr lang="en-US" sz="1200" dirty="0"/>
+          </a:p>
+        </p:txBody>
+      </p:sp>
+      <p:pic>
+        <p:nvPicPr>
+          <p:cNvPr id="4" name="Image 0" descr="/Users/brettmorrison/Claude/trustbutverify-site/build/deck-assets/qr-paper.png">    </p:cNvPr>
+          <p:cNvPicPr>
+            <a:picLocks noChangeAspect="1"/>
+          </p:cNvPicPr>
+          <p:nvPr/>
+        </p:nvPicPr>
+        <p:blipFill>
+          <a:blip r:embed="rId1"/>
+          <a:stretch>
+            <a:fillRect/>
+          </a:stretch>
+        </p:blipFill>
+        <p:spPr>
+          <a:xfrm>
+            <a:off x="11091672" y="6382512"/>
+            <a:ext cx="384048" cy="384048"/>
+          </a:xfrm>
+          <a:prstGeom prst="rect">
+            <a:avLst/>
+          </a:prstGeom>
+        </p:spPr>
+      </p:pic>
+      <p:sp>
+        <p:nvSpPr>
+          <p:cNvPr id="5" name="Text 1"/>
+          <p:cNvSpPr/>
+          <p:nvPr/>
+        </p:nvSpPr>
+        <p:spPr>
+          <a:xfrm>
             <a:off x="685800" y="1554480"/>
             <a:ext cx="10789920" cy="2194560"/>
           </a:xfrm>
@@ -6102,7 +6858,7 @@
       </p:sp>
       <p:sp>
         <p:nvSpPr>
-          <p:cNvPr id="4" name="Text 1"/>
+          <p:cNvPr id="6" name="Text 2"/>
           <p:cNvSpPr/>
           <p:nvPr/>
         </p:nvSpPr>
@@ -6202,6 +6958,69 @@
         </p:nvSpPr>
         <p:spPr>
           <a:xfrm>
+            <a:off x="685800" y="6400800"/>
+            <a:ext cx="5486400" cy="384048"/>
+          </a:xfrm>
+          <a:prstGeom prst="rect">
+            <a:avLst/>
+          </a:prstGeom>
+          <a:noFill/>
+          <a:ln/>
+        </p:spPr>
+        <p:txBody>
+          <a:bodyPr wrap="square" lIns="0" tIns="0" rIns="0" bIns="0" rtlCol="0" anchor="ctr"/>
+          <a:lstStyle/>
+          <a:p>
+            <a:pPr indent="0" marL="0">
+              <a:buNone/>
+            </a:pPr>
+            <a:r>
+              <a:rPr lang="en-US" sz="1200" dirty="0">
+                <a:solidFill>
+                  <a:srgbClr val="5A5A5A"/>
+                </a:solidFill>
+                <a:latin typeface="Arial" pitchFamily="34" charset="0"/>
+                <a:ea typeface="Arial" pitchFamily="34" charset="-122"/>
+                <a:cs typeface="Arial" pitchFamily="34" charset="-120"/>
+              </a:rPr>
+              <a:t>trustbutverifyproject.org</a:t>
+            </a:r>
+            <a:endParaRPr lang="en-US" sz="1200" dirty="0"/>
+          </a:p>
+        </p:txBody>
+      </p:sp>
+      <p:pic>
+        <p:nvPicPr>
+          <p:cNvPr id="4" name="Image 0" descr="/Users/brettmorrison/Claude/trustbutverify-site/build/deck-assets/qr-blue.png">    </p:cNvPr>
+          <p:cNvPicPr>
+            <a:picLocks noChangeAspect="1"/>
+          </p:cNvPicPr>
+          <p:nvPr/>
+        </p:nvPicPr>
+        <p:blipFill>
+          <a:blip r:embed="rId1"/>
+          <a:stretch>
+            <a:fillRect/>
+          </a:stretch>
+        </p:blipFill>
+        <p:spPr>
+          <a:xfrm>
+            <a:off x="11091672" y="6382512"/>
+            <a:ext cx="384048" cy="384048"/>
+          </a:xfrm>
+          <a:prstGeom prst="rect">
+            <a:avLst/>
+          </a:prstGeom>
+        </p:spPr>
+      </p:pic>
+      <p:sp>
+        <p:nvSpPr>
+          <p:cNvPr id="5" name="Text 1"/>
+          <p:cNvSpPr/>
+          <p:nvPr/>
+        </p:nvSpPr>
+        <p:spPr>
+          <a:xfrm>
             <a:off x="685800" y="502920"/>
             <a:ext cx="10789920" cy="1097280"/>
           </a:xfrm>
@@ -6235,7 +7054,7 @@
       </p:sp>
       <p:sp>
         <p:nvSpPr>
-          <p:cNvPr id="4" name="Text 1"/>
+          <p:cNvPr id="6" name="Text 2"/>
           <p:cNvSpPr/>
           <p:nvPr/>
         </p:nvSpPr>
@@ -6297,7 +7116,7 @@
       </p:sp>
       <p:sp>
         <p:nvSpPr>
-          <p:cNvPr id="5" name="Shape 2"/>
+          <p:cNvPr id="7" name="Shape 3"/>
           <p:cNvSpPr/>
           <p:nvPr/>
         </p:nvSpPr>
@@ -6322,7 +7141,7 @@
       </p:sp>
       <p:sp>
         <p:nvSpPr>
-          <p:cNvPr id="6" name="Text 3"/>
+          <p:cNvPr id="8" name="Text 4"/>
           <p:cNvSpPr/>
           <p:nvPr/>
         </p:nvSpPr>
@@ -6384,7 +7203,7 @@
       </p:sp>
       <p:sp>
         <p:nvSpPr>
-          <p:cNvPr id="7" name="Text 4"/>
+          <p:cNvPr id="9" name="Text 5"/>
           <p:cNvSpPr/>
           <p:nvPr/>
         </p:nvSpPr>
@@ -6461,6 +7280,69 @@
         </p:nvSpPr>
         <p:spPr>
           <a:xfrm>
+            <a:off x="685800" y="6400800"/>
+            <a:ext cx="5486400" cy="384048"/>
+          </a:xfrm>
+          <a:prstGeom prst="rect">
+            <a:avLst/>
+          </a:prstGeom>
+          <a:noFill/>
+          <a:ln/>
+        </p:spPr>
+        <p:txBody>
+          <a:bodyPr wrap="square" lIns="0" tIns="0" rIns="0" bIns="0" rtlCol="0" anchor="ctr"/>
+          <a:lstStyle/>
+          <a:p>
+            <a:pPr indent="0" marL="0">
+              <a:buNone/>
+            </a:pPr>
+            <a:r>
+              <a:rPr lang="en-US" sz="1200" dirty="0">
+                <a:solidFill>
+                  <a:srgbClr val="5A5A5A"/>
+                </a:solidFill>
+                <a:latin typeface="Arial" pitchFamily="34" charset="0"/>
+                <a:ea typeface="Arial" pitchFamily="34" charset="-122"/>
+                <a:cs typeface="Arial" pitchFamily="34" charset="-120"/>
+              </a:rPr>
+              <a:t>trustbutverifyproject.org</a:t>
+            </a:r>
+            <a:endParaRPr lang="en-US" sz="1200" dirty="0"/>
+          </a:p>
+        </p:txBody>
+      </p:sp>
+      <p:pic>
+        <p:nvPicPr>
+          <p:cNvPr id="4" name="Image 0" descr="/Users/brettmorrison/Claude/trustbutverify-site/build/deck-assets/qr-blue.png">    </p:cNvPr>
+          <p:cNvPicPr>
+            <a:picLocks noChangeAspect="1"/>
+          </p:cNvPicPr>
+          <p:nvPr/>
+        </p:nvPicPr>
+        <p:blipFill>
+          <a:blip r:embed="rId1"/>
+          <a:stretch>
+            <a:fillRect/>
+          </a:stretch>
+        </p:blipFill>
+        <p:spPr>
+          <a:xfrm>
+            <a:off x="11091672" y="6382512"/>
+            <a:ext cx="384048" cy="384048"/>
+          </a:xfrm>
+          <a:prstGeom prst="rect">
+            <a:avLst/>
+          </a:prstGeom>
+        </p:spPr>
+      </p:pic>
+      <p:sp>
+        <p:nvSpPr>
+          <p:cNvPr id="5" name="Text 1"/>
+          <p:cNvSpPr/>
+          <p:nvPr/>
+        </p:nvSpPr>
+        <p:spPr>
+          <a:xfrm>
             <a:off x="685800" y="502920"/>
             <a:ext cx="10789920" cy="1097280"/>
           </a:xfrm>
@@ -6494,7 +7376,7 @@
       </p:sp>
       <p:sp>
         <p:nvSpPr>
-          <p:cNvPr id="4" name="Text 1"/>
+          <p:cNvPr id="6" name="Text 2"/>
           <p:cNvSpPr/>
           <p:nvPr/>
         </p:nvSpPr>
@@ -6533,7 +7415,7 @@
       </p:sp>
       <p:sp>
         <p:nvSpPr>
-          <p:cNvPr id="5" name="Text 2"/>
+          <p:cNvPr id="7" name="Text 3"/>
           <p:cNvSpPr/>
           <p:nvPr/>
         </p:nvSpPr>
@@ -6572,7 +7454,7 @@
       </p:sp>
       <p:sp>
         <p:nvSpPr>
-          <p:cNvPr id="6" name="Text 3"/>
+          <p:cNvPr id="8" name="Text 4"/>
           <p:cNvSpPr/>
           <p:nvPr/>
         </p:nvSpPr>
@@ -6611,7 +7493,7 @@
       </p:sp>
       <p:sp>
         <p:nvSpPr>
-          <p:cNvPr id="7" name="Text 4"/>
+          <p:cNvPr id="9" name="Text 5"/>
           <p:cNvSpPr/>
           <p:nvPr/>
         </p:nvSpPr>
@@ -6650,7 +7532,7 @@
       </p:sp>
       <p:sp>
         <p:nvSpPr>
-          <p:cNvPr id="8" name="Text 5"/>
+          <p:cNvPr id="10" name="Text 6"/>
           <p:cNvSpPr/>
           <p:nvPr/>
         </p:nvSpPr>
@@ -6689,7 +7571,7 @@
       </p:sp>
       <p:sp>
         <p:nvSpPr>
-          <p:cNvPr id="9" name="Text 6"/>
+          <p:cNvPr id="11" name="Text 7"/>
           <p:cNvSpPr/>
           <p:nvPr/>
         </p:nvSpPr>
@@ -6728,7 +7610,7 @@
       </p:sp>
       <p:sp>
         <p:nvSpPr>
-          <p:cNvPr id="10" name="Text 7"/>
+          <p:cNvPr id="12" name="Text 8"/>
           <p:cNvSpPr/>
           <p:nvPr/>
         </p:nvSpPr>
@@ -6767,7 +7649,7 @@
       </p:sp>
       <p:sp>
         <p:nvSpPr>
-          <p:cNvPr id="11" name="Text 8"/>
+          <p:cNvPr id="13" name="Text 9"/>
           <p:cNvSpPr/>
           <p:nvPr/>
         </p:nvSpPr>
@@ -6806,7 +7688,7 @@
       </p:sp>
       <p:sp>
         <p:nvSpPr>
-          <p:cNvPr id="12" name="Text 9"/>
+          <p:cNvPr id="14" name="Text 10"/>
           <p:cNvSpPr/>
           <p:nvPr/>
         </p:nvSpPr>
@@ -6883,6 +7765,69 @@
         </p:nvSpPr>
         <p:spPr>
           <a:xfrm>
+            <a:off x="685800" y="6400800"/>
+            <a:ext cx="5486400" cy="384048"/>
+          </a:xfrm>
+          <a:prstGeom prst="rect">
+            <a:avLst/>
+          </a:prstGeom>
+          <a:noFill/>
+          <a:ln/>
+        </p:spPr>
+        <p:txBody>
+          <a:bodyPr wrap="square" lIns="0" tIns="0" rIns="0" bIns="0" rtlCol="0" anchor="ctr"/>
+          <a:lstStyle/>
+          <a:p>
+            <a:pPr indent="0" marL="0">
+              <a:buNone/>
+            </a:pPr>
+            <a:r>
+              <a:rPr lang="en-US" sz="1200" dirty="0">
+                <a:solidFill>
+                  <a:srgbClr val="9A958C"/>
+                </a:solidFill>
+                <a:latin typeface="Arial" pitchFamily="34" charset="0"/>
+                <a:ea typeface="Arial" pitchFamily="34" charset="-122"/>
+                <a:cs typeface="Arial" pitchFamily="34" charset="-120"/>
+              </a:rPr>
+              <a:t>trustbutverifyproject.org</a:t>
+            </a:r>
+            <a:endParaRPr lang="en-US" sz="1200" dirty="0"/>
+          </a:p>
+        </p:txBody>
+      </p:sp>
+      <p:pic>
+        <p:nvPicPr>
+          <p:cNvPr id="4" name="Image 0" descr="/Users/brettmorrison/Claude/trustbutverify-site/build/deck-assets/qr-paper.png">    </p:cNvPr>
+          <p:cNvPicPr>
+            <a:picLocks noChangeAspect="1"/>
+          </p:cNvPicPr>
+          <p:nvPr/>
+        </p:nvPicPr>
+        <p:blipFill>
+          <a:blip r:embed="rId1"/>
+          <a:stretch>
+            <a:fillRect/>
+          </a:stretch>
+        </p:blipFill>
+        <p:spPr>
+          <a:xfrm>
+            <a:off x="11091672" y="6382512"/>
+            <a:ext cx="384048" cy="384048"/>
+          </a:xfrm>
+          <a:prstGeom prst="rect">
+            <a:avLst/>
+          </a:prstGeom>
+        </p:spPr>
+      </p:pic>
+      <p:sp>
+        <p:nvSpPr>
+          <p:cNvPr id="5" name="Text 1"/>
+          <p:cNvSpPr/>
+          <p:nvPr/>
+        </p:nvSpPr>
+        <p:spPr>
+          <a:xfrm>
             <a:off x="685800" y="1828800"/>
             <a:ext cx="10789920" cy="2011680"/>
           </a:xfrm>
@@ -6911,7 +7856,7 @@
                 <a:ea typeface="Arial" pitchFamily="34" charset="-122"/>
                 <a:cs typeface="Arial" pitchFamily="34" charset="-120"/>
               </a:rPr>
-              <a:t>You don't have to get</a:t>
+              <a:t>You can stay trusting,</a:t>
             </a:r>
             <a:endParaRPr lang="en-US" sz="5200" dirty="0"/>
           </a:p>
@@ -6931,7 +7876,7 @@
                 <a:ea typeface="Arial" pitchFamily="34" charset="-122"/>
                 <a:cs typeface="Arial" pitchFamily="34" charset="-120"/>
               </a:rPr>
-              <a:t>suspicious of everybody.</a:t>
+              <a:t>but add a pause.</a:t>
             </a:r>
             <a:endParaRPr lang="en-US" sz="5200" dirty="0"/>
           </a:p>
@@ -6939,7 +7884,7 @@
       </p:sp>
       <p:sp>
         <p:nvSpPr>
-          <p:cNvPr id="4" name="Text 1"/>
+          <p:cNvPr id="6" name="Text 2"/>
           <p:cNvSpPr/>
           <p:nvPr/>
         </p:nvSpPr>
@@ -6970,48 +7915,9 @@
                 <a:ea typeface="Arial" pitchFamily="34" charset="-122"/>
                 <a:cs typeface="Arial" pitchFamily="34" charset="-120"/>
               </a:rPr>
-              <a:t>You just add one step.</a:t>
+              <a:t>That's the whole thing.</a:t>
             </a:r>
             <a:endParaRPr lang="en-US" sz="4000" dirty="0"/>
-          </a:p>
-        </p:txBody>
-      </p:sp>
-      <p:sp>
-        <p:nvSpPr>
-          <p:cNvPr id="5" name="Text 2"/>
-          <p:cNvSpPr/>
-          <p:nvPr/>
-        </p:nvSpPr>
-        <p:spPr>
-          <a:xfrm>
-            <a:off x="685800" y="5760720"/>
-            <a:ext cx="10789920" cy="457200"/>
-          </a:xfrm>
-          <a:prstGeom prst="rect">
-            <a:avLst/>
-          </a:prstGeom>
-          <a:noFill/>
-          <a:ln/>
-        </p:spPr>
-        <p:txBody>
-          <a:bodyPr wrap="square" lIns="0" tIns="0" rIns="0" bIns="0" rtlCol="0" anchor="ctr"/>
-          <a:lstStyle/>
-          <a:p>
-            <a:pPr indent="0" marL="0">
-              <a:buNone/>
-            </a:pPr>
-            <a:r>
-              <a:rPr lang="en-US" sz="1800" dirty="0">
-                <a:solidFill>
-                  <a:srgbClr val="9A958C"/>
-                </a:solidFill>
-                <a:latin typeface="Arial" pitchFamily="34" charset="0"/>
-                <a:ea typeface="Arial" pitchFamily="34" charset="-122"/>
-                <a:cs typeface="Arial" pitchFamily="34" charset="-120"/>
-              </a:rPr>
-              <a:t>trustbutverifyproject.org</a:t>
-            </a:r>
-            <a:endParaRPr lang="en-US" sz="1800" dirty="0"/>
           </a:p>
         </p:txBody>
       </p:sp>
@@ -7055,6 +7961,69 @@
         </p:nvSpPr>
         <p:spPr>
           <a:xfrm>
+            <a:off x="685800" y="6400800"/>
+            <a:ext cx="5486400" cy="384048"/>
+          </a:xfrm>
+          <a:prstGeom prst="rect">
+            <a:avLst/>
+          </a:prstGeom>
+          <a:noFill/>
+          <a:ln/>
+        </p:spPr>
+        <p:txBody>
+          <a:bodyPr wrap="square" lIns="0" tIns="0" rIns="0" bIns="0" rtlCol="0" anchor="ctr"/>
+          <a:lstStyle/>
+          <a:p>
+            <a:pPr indent="0" marL="0">
+              <a:buNone/>
+            </a:pPr>
+            <a:r>
+              <a:rPr lang="en-US" sz="1200" dirty="0">
+                <a:solidFill>
+                  <a:srgbClr val="5A5A5A"/>
+                </a:solidFill>
+                <a:latin typeface="Arial" pitchFamily="34" charset="0"/>
+                <a:ea typeface="Arial" pitchFamily="34" charset="-122"/>
+                <a:cs typeface="Arial" pitchFamily="34" charset="-120"/>
+              </a:rPr>
+              <a:t>trustbutverifyproject.org</a:t>
+            </a:r>
+            <a:endParaRPr lang="en-US" sz="1200" dirty="0"/>
+          </a:p>
+        </p:txBody>
+      </p:sp>
+      <p:pic>
+        <p:nvPicPr>
+          <p:cNvPr id="4" name="Image 0" descr="/Users/brettmorrison/Claude/trustbutverify-site/build/deck-assets/qr-blue.png">    </p:cNvPr>
+          <p:cNvPicPr>
+            <a:picLocks noChangeAspect="1"/>
+          </p:cNvPicPr>
+          <p:nvPr/>
+        </p:nvPicPr>
+        <p:blipFill>
+          <a:blip r:embed="rId1"/>
+          <a:stretch>
+            <a:fillRect/>
+          </a:stretch>
+        </p:blipFill>
+        <p:spPr>
+          <a:xfrm>
+            <a:off x="11091672" y="6382512"/>
+            <a:ext cx="384048" cy="384048"/>
+          </a:xfrm>
+          <a:prstGeom prst="rect">
+            <a:avLst/>
+          </a:prstGeom>
+        </p:spPr>
+      </p:pic>
+      <p:sp>
+        <p:nvSpPr>
+          <p:cNvPr id="5" name="Text 1"/>
+          <p:cNvSpPr/>
+          <p:nvPr/>
+        </p:nvSpPr>
+        <p:spPr>
+          <a:xfrm>
             <a:off x="685800" y="502920"/>
             <a:ext cx="10789920" cy="1097280"/>
           </a:xfrm>
@@ -7088,7 +8057,7 @@
       </p:sp>
       <p:sp>
         <p:nvSpPr>
-          <p:cNvPr id="4" name="Text 1"/>
+          <p:cNvPr id="6" name="Text 2"/>
           <p:cNvSpPr/>
           <p:nvPr/>
         </p:nvSpPr>
@@ -7127,7 +8096,7 @@
       </p:sp>
       <p:sp>
         <p:nvSpPr>
-          <p:cNvPr id="5" name="Shape 2"/>
+          <p:cNvPr id="7" name="Shape 3"/>
           <p:cNvSpPr/>
           <p:nvPr/>
         </p:nvSpPr>
@@ -7147,7 +8116,7 @@
       </p:sp>
       <p:sp>
         <p:nvSpPr>
-          <p:cNvPr id="6" name="Text 3"/>
+          <p:cNvPr id="8" name="Text 4"/>
           <p:cNvSpPr/>
           <p:nvPr/>
         </p:nvSpPr>
@@ -7186,7 +8155,7 @@
       </p:sp>
       <p:sp>
         <p:nvSpPr>
-          <p:cNvPr id="7" name="Text 4"/>
+          <p:cNvPr id="9" name="Text 5"/>
           <p:cNvSpPr/>
           <p:nvPr/>
         </p:nvSpPr>
@@ -7225,7 +8194,7 @@
       </p:sp>
       <p:sp>
         <p:nvSpPr>
-          <p:cNvPr id="8" name="Text 5"/>
+          <p:cNvPr id="10" name="Text 6"/>
           <p:cNvSpPr/>
           <p:nvPr/>
         </p:nvSpPr>
@@ -7264,7 +8233,7 @@
       </p:sp>
       <p:sp>
         <p:nvSpPr>
-          <p:cNvPr id="9" name="Shape 6"/>
+          <p:cNvPr id="11" name="Shape 7"/>
           <p:cNvSpPr/>
           <p:nvPr/>
         </p:nvSpPr>
@@ -7284,7 +8253,7 @@
       </p:sp>
       <p:sp>
         <p:nvSpPr>
-          <p:cNvPr id="10" name="Text 7"/>
+          <p:cNvPr id="12" name="Text 8"/>
           <p:cNvSpPr/>
           <p:nvPr/>
         </p:nvSpPr>
@@ -7323,7 +8292,7 @@
       </p:sp>
       <p:sp>
         <p:nvSpPr>
-          <p:cNvPr id="11" name="Text 8"/>
+          <p:cNvPr id="13" name="Text 9"/>
           <p:cNvSpPr/>
           <p:nvPr/>
         </p:nvSpPr>
@@ -7362,7 +8331,7 @@
       </p:sp>
       <p:sp>
         <p:nvSpPr>
-          <p:cNvPr id="12" name="Text 9"/>
+          <p:cNvPr id="14" name="Text 10"/>
           <p:cNvSpPr/>
           <p:nvPr/>
         </p:nvSpPr>
@@ -7401,7 +8370,7 @@
       </p:sp>
       <p:sp>
         <p:nvSpPr>
-          <p:cNvPr id="13" name="Shape 10"/>
+          <p:cNvPr id="15" name="Shape 11"/>
           <p:cNvSpPr/>
           <p:nvPr/>
         </p:nvSpPr>
@@ -7421,7 +8390,7 @@
       </p:sp>
       <p:sp>
         <p:nvSpPr>
-          <p:cNvPr id="14" name="Text 11"/>
+          <p:cNvPr id="16" name="Text 12"/>
           <p:cNvSpPr/>
           <p:nvPr/>
         </p:nvSpPr>
@@ -7460,7 +8429,7 @@
       </p:sp>
       <p:sp>
         <p:nvSpPr>
-          <p:cNvPr id="15" name="Text 12"/>
+          <p:cNvPr id="17" name="Text 13"/>
           <p:cNvSpPr/>
           <p:nvPr/>
         </p:nvSpPr>
@@ -7499,7 +8468,7 @@
       </p:sp>
       <p:sp>
         <p:nvSpPr>
-          <p:cNvPr id="16" name="Text 13"/>
+          <p:cNvPr id="18" name="Text 14"/>
           <p:cNvSpPr/>
           <p:nvPr/>
         </p:nvSpPr>
@@ -7576,6 +8545,69 @@
         </p:nvSpPr>
         <p:spPr>
           <a:xfrm>
+            <a:off x="685800" y="6400800"/>
+            <a:ext cx="5486400" cy="384048"/>
+          </a:xfrm>
+          <a:prstGeom prst="rect">
+            <a:avLst/>
+          </a:prstGeom>
+          <a:noFill/>
+          <a:ln/>
+        </p:spPr>
+        <p:txBody>
+          <a:bodyPr wrap="square" lIns="0" tIns="0" rIns="0" bIns="0" rtlCol="0" anchor="ctr"/>
+          <a:lstStyle/>
+          <a:p>
+            <a:pPr indent="0" marL="0">
+              <a:buNone/>
+            </a:pPr>
+            <a:r>
+              <a:rPr lang="en-US" sz="1200" dirty="0">
+                <a:solidFill>
+                  <a:srgbClr val="5A5A5A"/>
+                </a:solidFill>
+                <a:latin typeface="Arial" pitchFamily="34" charset="0"/>
+                <a:ea typeface="Arial" pitchFamily="34" charset="-122"/>
+                <a:cs typeface="Arial" pitchFamily="34" charset="-120"/>
+              </a:rPr>
+              <a:t>trustbutverifyproject.org</a:t>
+            </a:r>
+            <a:endParaRPr lang="en-US" sz="1200" dirty="0"/>
+          </a:p>
+        </p:txBody>
+      </p:sp>
+      <p:pic>
+        <p:nvPicPr>
+          <p:cNvPr id="4" name="Image 0" descr="/Users/brettmorrison/Claude/trustbutverify-site/build/deck-assets/qr-blue.png">    </p:cNvPr>
+          <p:cNvPicPr>
+            <a:picLocks noChangeAspect="1"/>
+          </p:cNvPicPr>
+          <p:nvPr/>
+        </p:nvPicPr>
+        <p:blipFill>
+          <a:blip r:embed="rId1"/>
+          <a:stretch>
+            <a:fillRect/>
+          </a:stretch>
+        </p:blipFill>
+        <p:spPr>
+          <a:xfrm>
+            <a:off x="11091672" y="6382512"/>
+            <a:ext cx="384048" cy="384048"/>
+          </a:xfrm>
+          <a:prstGeom prst="rect">
+            <a:avLst/>
+          </a:prstGeom>
+        </p:spPr>
+      </p:pic>
+      <p:sp>
+        <p:nvSpPr>
+          <p:cNvPr id="5" name="Text 1"/>
+          <p:cNvSpPr/>
+          <p:nvPr/>
+        </p:nvSpPr>
+        <p:spPr>
+          <a:xfrm>
             <a:off x="685800" y="502920"/>
             <a:ext cx="10789920" cy="1097280"/>
           </a:xfrm>
@@ -7609,7 +8641,7 @@
       </p:sp>
       <p:sp>
         <p:nvSpPr>
-          <p:cNvPr id="4" name="Text 1"/>
+          <p:cNvPr id="6" name="Text 2"/>
           <p:cNvSpPr/>
           <p:nvPr/>
         </p:nvSpPr>
@@ -7648,7 +8680,7 @@
       </p:sp>
       <p:sp>
         <p:nvSpPr>
-          <p:cNvPr id="5" name="Text 2"/>
+          <p:cNvPr id="7" name="Text 3"/>
           <p:cNvSpPr/>
           <p:nvPr/>
         </p:nvSpPr>
@@ -7687,7 +8719,7 @@
       </p:sp>
       <p:sp>
         <p:nvSpPr>
-          <p:cNvPr id="6" name="Text 3"/>
+          <p:cNvPr id="8" name="Text 4"/>
           <p:cNvSpPr/>
           <p:nvPr/>
         </p:nvSpPr>
@@ -7726,7 +8758,7 @@
       </p:sp>
       <p:sp>
         <p:nvSpPr>
-          <p:cNvPr id="7" name="Shape 4"/>
+          <p:cNvPr id="9" name="Shape 5"/>
           <p:cNvSpPr/>
           <p:nvPr/>
         </p:nvSpPr>
@@ -7746,7 +8778,7 @@
       </p:sp>
       <p:sp>
         <p:nvSpPr>
-          <p:cNvPr id="8" name="Text 5"/>
+          <p:cNvPr id="10" name="Text 6"/>
           <p:cNvSpPr/>
           <p:nvPr/>
         </p:nvSpPr>
@@ -7837,7 +8869,7 @@
       </p:sp>
       <p:sp>
         <p:nvSpPr>
-          <p:cNvPr id="9" name="Text 6"/>
+          <p:cNvPr id="11" name="Text 7"/>
           <p:cNvSpPr/>
           <p:nvPr/>
         </p:nvSpPr>
@@ -7914,6 +8946,69 @@
         </p:nvSpPr>
         <p:spPr>
           <a:xfrm>
+            <a:off x="685800" y="6400800"/>
+            <a:ext cx="5486400" cy="384048"/>
+          </a:xfrm>
+          <a:prstGeom prst="rect">
+            <a:avLst/>
+          </a:prstGeom>
+          <a:noFill/>
+          <a:ln/>
+        </p:spPr>
+        <p:txBody>
+          <a:bodyPr wrap="square" lIns="0" tIns="0" rIns="0" bIns="0" rtlCol="0" anchor="ctr"/>
+          <a:lstStyle/>
+          <a:p>
+            <a:pPr indent="0" marL="0">
+              <a:buNone/>
+            </a:pPr>
+            <a:r>
+              <a:rPr lang="en-US" sz="1200" dirty="0">
+                <a:solidFill>
+                  <a:srgbClr val="9A958C"/>
+                </a:solidFill>
+                <a:latin typeface="Arial" pitchFamily="34" charset="0"/>
+                <a:ea typeface="Arial" pitchFamily="34" charset="-122"/>
+                <a:cs typeface="Arial" pitchFamily="34" charset="-120"/>
+              </a:rPr>
+              <a:t>trustbutverifyproject.org</a:t>
+            </a:r>
+            <a:endParaRPr lang="en-US" sz="1200" dirty="0"/>
+          </a:p>
+        </p:txBody>
+      </p:sp>
+      <p:pic>
+        <p:nvPicPr>
+          <p:cNvPr id="4" name="Image 0" descr="/Users/brettmorrison/Claude/trustbutverify-site/build/deck-assets/qr-paper.png">    </p:cNvPr>
+          <p:cNvPicPr>
+            <a:picLocks noChangeAspect="1"/>
+          </p:cNvPicPr>
+          <p:nvPr/>
+        </p:nvPicPr>
+        <p:blipFill>
+          <a:blip r:embed="rId1"/>
+          <a:stretch>
+            <a:fillRect/>
+          </a:stretch>
+        </p:blipFill>
+        <p:spPr>
+          <a:xfrm>
+            <a:off x="11091672" y="6382512"/>
+            <a:ext cx="384048" cy="384048"/>
+          </a:xfrm>
+          <a:prstGeom prst="rect">
+            <a:avLst/>
+          </a:prstGeom>
+        </p:spPr>
+      </p:pic>
+      <p:sp>
+        <p:nvSpPr>
+          <p:cNvPr id="5" name="Text 1"/>
+          <p:cNvSpPr/>
+          <p:nvPr/>
+        </p:nvSpPr>
+        <p:spPr>
+          <a:xfrm>
             <a:off x="685800" y="2194560"/>
             <a:ext cx="10058400" cy="1280160"/>
           </a:xfrm>
@@ -7947,7 +9042,7 @@
       </p:sp>
       <p:sp>
         <p:nvSpPr>
-          <p:cNvPr id="4" name="Text 1"/>
+          <p:cNvPr id="6" name="Text 2"/>
           <p:cNvSpPr/>
           <p:nvPr/>
         </p:nvSpPr>
@@ -8024,6 +9119,69 @@
         </p:nvSpPr>
         <p:spPr>
           <a:xfrm>
+            <a:off x="685800" y="6400800"/>
+            <a:ext cx="5486400" cy="384048"/>
+          </a:xfrm>
+          <a:prstGeom prst="rect">
+            <a:avLst/>
+          </a:prstGeom>
+          <a:noFill/>
+          <a:ln/>
+        </p:spPr>
+        <p:txBody>
+          <a:bodyPr wrap="square" lIns="0" tIns="0" rIns="0" bIns="0" rtlCol="0" anchor="ctr"/>
+          <a:lstStyle/>
+          <a:p>
+            <a:pPr indent="0" marL="0">
+              <a:buNone/>
+            </a:pPr>
+            <a:r>
+              <a:rPr lang="en-US" sz="1200" dirty="0">
+                <a:solidFill>
+                  <a:srgbClr val="5A5A5A"/>
+                </a:solidFill>
+                <a:latin typeface="Arial" pitchFamily="34" charset="0"/>
+                <a:ea typeface="Arial" pitchFamily="34" charset="-122"/>
+                <a:cs typeface="Arial" pitchFamily="34" charset="-120"/>
+              </a:rPr>
+              <a:t>trustbutverifyproject.org</a:t>
+            </a:r>
+            <a:endParaRPr lang="en-US" sz="1200" dirty="0"/>
+          </a:p>
+        </p:txBody>
+      </p:sp>
+      <p:pic>
+        <p:nvPicPr>
+          <p:cNvPr id="4" name="Image 0" descr="/Users/brettmorrison/Claude/trustbutverify-site/build/deck-assets/qr-blue.png">    </p:cNvPr>
+          <p:cNvPicPr>
+            <a:picLocks noChangeAspect="1"/>
+          </p:cNvPicPr>
+          <p:nvPr/>
+        </p:nvPicPr>
+        <p:blipFill>
+          <a:blip r:embed="rId1"/>
+          <a:stretch>
+            <a:fillRect/>
+          </a:stretch>
+        </p:blipFill>
+        <p:spPr>
+          <a:xfrm>
+            <a:off x="11091672" y="6382512"/>
+            <a:ext cx="384048" cy="384048"/>
+          </a:xfrm>
+          <a:prstGeom prst="rect">
+            <a:avLst/>
+          </a:prstGeom>
+        </p:spPr>
+      </p:pic>
+      <p:sp>
+        <p:nvSpPr>
+          <p:cNvPr id="5" name="Text 1"/>
+          <p:cNvSpPr/>
+          <p:nvPr/>
+        </p:nvSpPr>
+        <p:spPr>
+          <a:xfrm>
             <a:off x="685800" y="1234440"/>
             <a:ext cx="2377440" cy="3931920"/>
           </a:xfrm>
@@ -8057,7 +9215,7 @@
       </p:sp>
       <p:sp>
         <p:nvSpPr>
-          <p:cNvPr id="4" name="Text 1"/>
+          <p:cNvPr id="6" name="Text 2"/>
           <p:cNvSpPr/>
           <p:nvPr/>
         </p:nvSpPr>
@@ -8119,7 +9277,7 @@
       </p:sp>
       <p:sp>
         <p:nvSpPr>
-          <p:cNvPr id="5" name="Text 2"/>
+          <p:cNvPr id="7" name="Text 3"/>
           <p:cNvSpPr/>
           <p:nvPr/>
         </p:nvSpPr>
@@ -8219,6 +9377,69 @@
         </p:nvSpPr>
         <p:spPr>
           <a:xfrm>
+            <a:off x="685800" y="6400800"/>
+            <a:ext cx="5486400" cy="384048"/>
+          </a:xfrm>
+          <a:prstGeom prst="rect">
+            <a:avLst/>
+          </a:prstGeom>
+          <a:noFill/>
+          <a:ln/>
+        </p:spPr>
+        <p:txBody>
+          <a:bodyPr wrap="square" lIns="0" tIns="0" rIns="0" bIns="0" rtlCol="0" anchor="ctr"/>
+          <a:lstStyle/>
+          <a:p>
+            <a:pPr indent="0" marL="0">
+              <a:buNone/>
+            </a:pPr>
+            <a:r>
+              <a:rPr lang="en-US" sz="1200" dirty="0">
+                <a:solidFill>
+                  <a:srgbClr val="5A5A5A"/>
+                </a:solidFill>
+                <a:latin typeface="Arial" pitchFamily="34" charset="0"/>
+                <a:ea typeface="Arial" pitchFamily="34" charset="-122"/>
+                <a:cs typeface="Arial" pitchFamily="34" charset="-120"/>
+              </a:rPr>
+              <a:t>trustbutverifyproject.org</a:t>
+            </a:r>
+            <a:endParaRPr lang="en-US" sz="1200" dirty="0"/>
+          </a:p>
+        </p:txBody>
+      </p:sp>
+      <p:pic>
+        <p:nvPicPr>
+          <p:cNvPr id="4" name="Image 0" descr="/Users/brettmorrison/Claude/trustbutverify-site/build/deck-assets/qr-blue.png">    </p:cNvPr>
+          <p:cNvPicPr>
+            <a:picLocks noChangeAspect="1"/>
+          </p:cNvPicPr>
+          <p:nvPr/>
+        </p:nvPicPr>
+        <p:blipFill>
+          <a:blip r:embed="rId1"/>
+          <a:stretch>
+            <a:fillRect/>
+          </a:stretch>
+        </p:blipFill>
+        <p:spPr>
+          <a:xfrm>
+            <a:off x="11091672" y="6382512"/>
+            <a:ext cx="384048" cy="384048"/>
+          </a:xfrm>
+          <a:prstGeom prst="rect">
+            <a:avLst/>
+          </a:prstGeom>
+        </p:spPr>
+      </p:pic>
+      <p:sp>
+        <p:nvSpPr>
+          <p:cNvPr id="5" name="Text 1"/>
+          <p:cNvSpPr/>
+          <p:nvPr/>
+        </p:nvSpPr>
+        <p:spPr>
+          <a:xfrm>
             <a:off x="685800" y="1234440"/>
             <a:ext cx="2377440" cy="3931920"/>
           </a:xfrm>
@@ -8252,7 +9473,7 @@
       </p:sp>
       <p:sp>
         <p:nvSpPr>
-          <p:cNvPr id="4" name="Text 1"/>
+          <p:cNvPr id="6" name="Text 2"/>
           <p:cNvSpPr/>
           <p:nvPr/>
         </p:nvSpPr>
@@ -8314,7 +9535,7 @@
       </p:sp>
       <p:sp>
         <p:nvSpPr>
-          <p:cNvPr id="5" name="Text 2"/>
+          <p:cNvPr id="7" name="Text 3"/>
           <p:cNvSpPr/>
           <p:nvPr/>
         </p:nvSpPr>
@@ -8414,6 +9635,69 @@
         </p:nvSpPr>
         <p:spPr>
           <a:xfrm>
+            <a:off x="685800" y="6400800"/>
+            <a:ext cx="5486400" cy="384048"/>
+          </a:xfrm>
+          <a:prstGeom prst="rect">
+            <a:avLst/>
+          </a:prstGeom>
+          <a:noFill/>
+          <a:ln/>
+        </p:spPr>
+        <p:txBody>
+          <a:bodyPr wrap="square" lIns="0" tIns="0" rIns="0" bIns="0" rtlCol="0" anchor="ctr"/>
+          <a:lstStyle/>
+          <a:p>
+            <a:pPr indent="0" marL="0">
+              <a:buNone/>
+            </a:pPr>
+            <a:r>
+              <a:rPr lang="en-US" sz="1200" dirty="0">
+                <a:solidFill>
+                  <a:srgbClr val="5A5A5A"/>
+                </a:solidFill>
+                <a:latin typeface="Arial" pitchFamily="34" charset="0"/>
+                <a:ea typeface="Arial" pitchFamily="34" charset="-122"/>
+                <a:cs typeface="Arial" pitchFamily="34" charset="-120"/>
+              </a:rPr>
+              <a:t>trustbutverifyproject.org</a:t>
+            </a:r>
+            <a:endParaRPr lang="en-US" sz="1200" dirty="0"/>
+          </a:p>
+        </p:txBody>
+      </p:sp>
+      <p:pic>
+        <p:nvPicPr>
+          <p:cNvPr id="4" name="Image 0" descr="/Users/brettmorrison/Claude/trustbutverify-site/build/deck-assets/qr-blue.png">    </p:cNvPr>
+          <p:cNvPicPr>
+            <a:picLocks noChangeAspect="1"/>
+          </p:cNvPicPr>
+          <p:nvPr/>
+        </p:nvPicPr>
+        <p:blipFill>
+          <a:blip r:embed="rId1"/>
+          <a:stretch>
+            <a:fillRect/>
+          </a:stretch>
+        </p:blipFill>
+        <p:spPr>
+          <a:xfrm>
+            <a:off x="11091672" y="6382512"/>
+            <a:ext cx="384048" cy="384048"/>
+          </a:xfrm>
+          <a:prstGeom prst="rect">
+            <a:avLst/>
+          </a:prstGeom>
+        </p:spPr>
+      </p:pic>
+      <p:sp>
+        <p:nvSpPr>
+          <p:cNvPr id="5" name="Text 1"/>
+          <p:cNvSpPr/>
+          <p:nvPr/>
+        </p:nvSpPr>
+        <p:spPr>
+          <a:xfrm>
             <a:off x="685800" y="1234440"/>
             <a:ext cx="2377440" cy="3931920"/>
           </a:xfrm>
@@ -8447,7 +9731,7 @@
       </p:sp>
       <p:sp>
         <p:nvSpPr>
-          <p:cNvPr id="4" name="Text 1"/>
+          <p:cNvPr id="6" name="Text 2"/>
           <p:cNvSpPr/>
           <p:nvPr/>
         </p:nvSpPr>
@@ -8489,7 +9773,7 @@
       </p:sp>
       <p:sp>
         <p:nvSpPr>
-          <p:cNvPr id="5" name="Text 2"/>
+          <p:cNvPr id="7" name="Text 3"/>
           <p:cNvSpPr/>
           <p:nvPr/>
         </p:nvSpPr>
@@ -8584,6 +9868,69 @@
       <p:sp>
         <p:nvSpPr>
           <p:cNvPr id="3" name="Text 0"/>
+          <p:cNvSpPr/>
+          <p:nvPr/>
+        </p:nvSpPr>
+        <p:spPr>
+          <a:xfrm>
+            <a:off x="685800" y="6400800"/>
+            <a:ext cx="5486400" cy="384048"/>
+          </a:xfrm>
+          <a:prstGeom prst="rect">
+            <a:avLst/>
+          </a:prstGeom>
+          <a:noFill/>
+          <a:ln/>
+        </p:spPr>
+        <p:txBody>
+          <a:bodyPr wrap="square" lIns="0" tIns="0" rIns="0" bIns="0" rtlCol="0" anchor="ctr"/>
+          <a:lstStyle/>
+          <a:p>
+            <a:pPr indent="0" marL="0">
+              <a:buNone/>
+            </a:pPr>
+            <a:r>
+              <a:rPr lang="en-US" sz="1200" dirty="0">
+                <a:solidFill>
+                  <a:srgbClr val="5A5A5A"/>
+                </a:solidFill>
+                <a:latin typeface="Arial" pitchFamily="34" charset="0"/>
+                <a:ea typeface="Arial" pitchFamily="34" charset="-122"/>
+                <a:cs typeface="Arial" pitchFamily="34" charset="-120"/>
+              </a:rPr>
+              <a:t>trustbutverifyproject.org</a:t>
+            </a:r>
+            <a:endParaRPr lang="en-US" sz="1200" dirty="0"/>
+          </a:p>
+        </p:txBody>
+      </p:sp>
+      <p:pic>
+        <p:nvPicPr>
+          <p:cNvPr id="4" name="Image 0" descr="/Users/brettmorrison/Claude/trustbutverify-site/build/deck-assets/qr-blue.png">    </p:cNvPr>
+          <p:cNvPicPr>
+            <a:picLocks noChangeAspect="1"/>
+          </p:cNvPicPr>
+          <p:nvPr/>
+        </p:nvPicPr>
+        <p:blipFill>
+          <a:blip r:embed="rId1"/>
+          <a:stretch>
+            <a:fillRect/>
+          </a:stretch>
+        </p:blipFill>
+        <p:spPr>
+          <a:xfrm>
+            <a:off x="11091672" y="6382512"/>
+            <a:ext cx="384048" cy="384048"/>
+          </a:xfrm>
+          <a:prstGeom prst="rect">
+            <a:avLst/>
+          </a:prstGeom>
+        </p:spPr>
+      </p:pic>
+      <p:sp>
+        <p:nvSpPr>
+          <p:cNvPr id="5" name="Text 1"/>
           <p:cNvSpPr/>
           <p:nvPr/>
         </p:nvSpPr>

</xml_diff>